<commit_message>
Add 100k data visualization and update PPTX
</commit_message>
<xml_diff>
--- a/UGV_FHE_Presentation.pptx
+++ b/UGV_FHE_Presentation.pptx
@@ -3575,6 +3575,30 @@
           </a:p>
         </p:txBody>
       </p:sp>
+      <p:pic>
+        <p:nvPicPr>
+          <p:cNvPr id="4" name="Picture 3" descr="glowsai_100k_data_distribution.png"/>
+          <p:cNvPicPr>
+            <a:picLocks noChangeAspect="1"/>
+          </p:cNvPicPr>
+          <p:nvPr/>
+        </p:nvPicPr>
+        <p:blipFill>
+          <a:blip r:embed="rId2"/>
+          <a:stretch>
+            <a:fillRect/>
+          </a:stretch>
+        </p:blipFill>
+        <p:spPr>
+          <a:xfrm>
+            <a:off x="4114800" y="1828800"/>
+            <a:ext cx="4572000" cy="2286000"/>
+          </a:xfrm>
+          <a:prstGeom prst="rect">
+            <a:avLst/>
+          </a:prstGeom>
+        </p:spPr>
+      </p:pic>
     </p:spTree>
   </p:cSld>
   <p:clrMapOvr>

</xml_diff>

<commit_message>
Add graph explanation to slide 6
</commit_message>
<xml_diff>
--- a/UGV_FHE_Presentation.pptx
+++ b/UGV_FHE_Presentation.pptx
@@ -3569,8 +3569,27 @@
             </a:r>
           </a:p>
           <a:p>
-            <a:r>
-              <a:t>실제 전장과 유사한 의도적 사이버 공격 패킷 주입</a:t>
+            <a:pPr lvl="1"/>
+            <a:r>
+              <a:t>데이터 분포 물리적 분석 (파란색: 정상 vs 빨간색: 해킹)</a:t>
+            </a:r>
+          </a:p>
+          <a:p>
+            <a:pPr lvl="2"/>
+            <a:r>
+              <a:t>[정상] 속도 50km/h 및 조향각 0(직진) 유지 안전 주행</a:t>
+            </a:r>
+          </a:p>
+          <a:p>
+            <a:pPr lvl="2"/>
+            <a:r>
+              <a:t>[해킹] 속도 85km/h 이상 과속 및 핸들 급조작(조향각 0.8)</a:t>
+            </a:r>
+          </a:p>
+          <a:p>
+            <a:pPr lvl="1"/>
+            <a:r>
+              <a:t>AI가 이 물리적 패턴 차이를 학습하여 즉각적인 방어 수행</a:t>
             </a:r>
           </a:p>
         </p:txBody>

</xml_diff>